<commit_message>
chore: upload executive summary and presentation pdf
</commit_message>
<xml_diff>
--- a/dissemination/Presentation.pptx
+++ b/dissemination/Presentation.pptx
@@ -755,7 +755,7 @@
         </p:nvSpPr>
         <p:spPr>
           <a:xfrm>
-            <a:off x="381300" y="685800"/>
+            <a:off x="381000" y="685800"/>
             <a:ext cx="6096000" cy="3429000"/>
           </a:xfrm>
           <a:custGeom>
@@ -7543,7 +7543,7 @@
         </p:nvPicPr>
         <p:blipFill>
           <a:blip r:embed="rId3">
-            <a:alphaModFix amt="14000"/>
+            <a:alphaModFix amt="30000"/>
           </a:blip>
           <a:stretch>
             <a:fillRect/>

</xml_diff>